<commit_message>
Pitch deck: Riscon logo assets, transparent slide mark PNG, generator updates
- Add riscon-logo.svg and riscon-mark.svg (frontend + pitch-deck)
- Render slide logo from SVG with transparent background (riscon-mark-slide.png)
- Rebuild CursorHackathon-Pitch.pptx/pdf; build_pitch_deck installs Pillow

Made-with: Cursor
</commit_message>
<xml_diff>
--- a/pitch-deck/CursorHackathon-Pitch.pptx
+++ b/pitch-deck/CursorHackathon-Pitch.pptx
@@ -3939,6 +3939,30 @@
           </a:p>
         </p:txBody>
       </p:sp>
+      <p:pic>
+        <p:nvPicPr>
+          <p:cNvPr id="23" name="Picture 22" descr="riscon-mark-slide.png"/>
+          <p:cNvPicPr>
+            <a:picLocks noChangeAspect="1"/>
+          </p:cNvPicPr>
+          <p:nvPr/>
+        </p:nvPicPr>
+        <p:blipFill>
+          <a:blip r:embed="rId2"/>
+          <a:stretch>
+            <a:fillRect/>
+          </a:stretch>
+        </p:blipFill>
+        <p:spPr>
+          <a:xfrm>
+            <a:off x="10116007" y="502920"/>
+            <a:ext cx="1572768" cy="1572768"/>
+          </a:xfrm>
+          <a:prstGeom prst="rect">
+            <a:avLst/>
+          </a:prstGeom>
+        </p:spPr>
+      </p:pic>
     </p:spTree>
   </p:cSld>
   <p:clrMapOvr>
@@ -4259,7 +4283,7 @@
         <p:spPr>
           <a:xfrm>
             <a:off x="502920" y="713232"/>
-            <a:ext cx="11185855" cy="914400"/>
+            <a:ext cx="11185855" cy="658368"/>
           </a:xfrm>
           <a:prstGeom prst="rect">
             <a:avLst/>
@@ -4274,7 +4298,7 @@
           <a:p>
             <a:pPr algn="l"/>
             <a:r>
-              <a:rPr sz="3400" b="1">
+              <a:rPr sz="3000" b="1">
                 <a:solidFill>
                   <a:srgbClr val="FFFFFF"/>
                 </a:solidFill>
@@ -4293,8 +4317,8 @@
         </p:nvSpPr>
         <p:spPr>
           <a:xfrm>
-            <a:off x="502920" y="1719072"/>
-            <a:ext cx="109728" cy="4636008"/>
+            <a:off x="502920" y="1426464"/>
+            <a:ext cx="109728" cy="4270248"/>
           </a:xfrm>
           <a:prstGeom prst="rect">
             <a:avLst/>
@@ -4336,8 +4360,8 @@
         </p:nvSpPr>
         <p:spPr>
           <a:xfrm>
-            <a:off x="502920" y="1719072"/>
-            <a:ext cx="11185855" cy="4636008"/>
+            <a:off x="502920" y="1426464"/>
+            <a:ext cx="11185855" cy="4270248"/>
           </a:xfrm>
           <a:prstGeom prst="roundRect">
             <a:avLst/>
@@ -4381,8 +4405,8 @@
         </p:nvSpPr>
         <p:spPr>
           <a:xfrm>
-            <a:off x="886968" y="2066544"/>
-            <a:ext cx="10472623" cy="4087368"/>
+            <a:off x="886968" y="1773936"/>
+            <a:ext cx="10472623" cy="3831336"/>
           </a:xfrm>
           <a:prstGeom prst="rect">
             <a:avLst/>
@@ -5019,6 +5043,148 @@
           </a:p>
         </p:txBody>
       </p:sp>
+      <p:sp>
+        <p:nvSpPr>
+          <p:cNvPr id="13" name="TextBox 12"/>
+          <p:cNvSpPr txBox="1"/>
+          <p:nvPr/>
+        </p:nvSpPr>
+        <p:spPr>
+          <a:xfrm>
+            <a:off x="7253935" y="5705857"/>
+            <a:ext cx="4434840" cy="649223"/>
+          </a:xfrm>
+          <a:prstGeom prst="rect">
+            <a:avLst/>
+          </a:prstGeom>
+          <a:noFill/>
+        </p:spPr>
+        <p:txBody>
+          <a:bodyPr wrap="square" anchor="b">
+            <a:noAutofit/>
+          </a:bodyPr>
+          <a:lstStyle/>
+          <a:p>
+            <a:pPr algn="r">
+              <a:lnSpc>
+                <a:spcPct val="100000"/>
+              </a:lnSpc>
+              <a:spcAft>
+                <a:spcPts val="0"/>
+              </a:spcAft>
+            </a:pPr>
+            <a:r>
+              <a:rPr sz="800">
+                <a:solidFill>
+                  <a:srgbClr val="7A88A3"/>
+                </a:solidFill>
+                <a:latin typeface="Calibri"/>
+              </a:rPr>
+              <a:t>CP&amp;R — Commercial products &amp; raw materials (industrial)</a:t>
+            </a:r>
+          </a:p>
+          <a:p>
+            <a:pPr algn="r">
+              <a:lnSpc>
+                <a:spcPct val="100000"/>
+              </a:lnSpc>
+              <a:spcAft>
+                <a:spcPts val="0"/>
+              </a:spcAft>
+            </a:pPr>
+            <a:r>
+              <a:rPr sz="800">
+                <a:solidFill>
+                  <a:srgbClr val="7A88A3"/>
+                </a:solidFill>
+                <a:latin typeface="Calibri"/>
+              </a:rPr>
+              <a:t>EU — European Union</a:t>
+            </a:r>
+          </a:p>
+          <a:p>
+            <a:pPr algn="r">
+              <a:lnSpc>
+                <a:spcPct val="100000"/>
+              </a:lnSpc>
+              <a:spcAft>
+                <a:spcPts val="0"/>
+              </a:spcAft>
+            </a:pPr>
+            <a:r>
+              <a:rPr sz="800">
+                <a:solidFill>
+                  <a:srgbClr val="7A88A3"/>
+                </a:solidFill>
+                <a:latin typeface="Calibri"/>
+              </a:rPr>
+              <a:t>ICP — Ideal customer profile</a:t>
+            </a:r>
+          </a:p>
+          <a:p>
+            <a:pPr algn="r">
+              <a:lnSpc>
+                <a:spcPct val="100000"/>
+              </a:lnSpc>
+              <a:spcAft>
+                <a:spcPts val="0"/>
+              </a:spcAft>
+            </a:pPr>
+            <a:r>
+              <a:rPr sz="800">
+                <a:solidFill>
+                  <a:srgbClr val="7A88A3"/>
+                </a:solidFill>
+                <a:latin typeface="Calibri"/>
+              </a:rPr>
+              <a:t>TAM — Total addressable market</a:t>
+            </a:r>
+          </a:p>
+          <a:p>
+            <a:pPr algn="r">
+              <a:lnSpc>
+                <a:spcPct val="100000"/>
+              </a:lnSpc>
+              <a:spcAft>
+                <a:spcPts val="0"/>
+              </a:spcAft>
+            </a:pPr>
+            <a:r>
+              <a:rPr sz="800">
+                <a:solidFill>
+                  <a:srgbClr val="7A88A3"/>
+                </a:solidFill>
+                <a:latin typeface="Calibri"/>
+              </a:rPr>
+              <a:t>US — United States</a:t>
+            </a:r>
+          </a:p>
+        </p:txBody>
+      </p:sp>
+      <p:pic>
+        <p:nvPicPr>
+          <p:cNvPr id="14" name="Picture 13" descr="riscon-mark-slide.png"/>
+          <p:cNvPicPr>
+            <a:picLocks noChangeAspect="1"/>
+          </p:cNvPicPr>
+          <p:nvPr/>
+        </p:nvPicPr>
+        <p:blipFill>
+          <a:blip r:embed="rId2"/>
+          <a:stretch>
+            <a:fillRect/>
+          </a:stretch>
+        </p:blipFill>
+        <p:spPr>
+          <a:xfrm>
+            <a:off x="10756087" y="502920"/>
+            <a:ext cx="932688" cy="932688"/>
+          </a:xfrm>
+          <a:prstGeom prst="rect">
+            <a:avLst/>
+          </a:prstGeom>
+        </p:spPr>
+      </p:pic>
     </p:spTree>
   </p:cSld>
   <p:clrMapOvr>
@@ -5374,7 +5540,7 @@
         <p:spPr>
           <a:xfrm>
             <a:off x="502920" y="1719072"/>
-            <a:ext cx="109728" cy="4636008"/>
+            <a:ext cx="109728" cy="3977639"/>
           </a:xfrm>
           <a:prstGeom prst="rect">
             <a:avLst/>
@@ -5417,7 +5583,7 @@
         <p:spPr>
           <a:xfrm>
             <a:off x="502920" y="1719072"/>
-            <a:ext cx="11185855" cy="4636008"/>
+            <a:ext cx="11185855" cy="3977640"/>
           </a:xfrm>
           <a:prstGeom prst="roundRect">
             <a:avLst/>
@@ -5462,7 +5628,7 @@
         <p:spPr>
           <a:xfrm>
             <a:off x="886968" y="2066544"/>
-            <a:ext cx="10472623" cy="4087368"/>
+            <a:ext cx="10472623" cy="3429000"/>
           </a:xfrm>
           <a:prstGeom prst="rect">
             <a:avLst/>
@@ -6003,6 +6169,91 @@
           </a:p>
         </p:txBody>
       </p:sp>
+      <p:sp>
+        <p:nvSpPr>
+          <p:cNvPr id="13" name="TextBox 12"/>
+          <p:cNvSpPr txBox="1"/>
+          <p:nvPr/>
+        </p:nvSpPr>
+        <p:spPr>
+          <a:xfrm>
+            <a:off x="7253935" y="6029554"/>
+            <a:ext cx="4434840" cy="325526"/>
+          </a:xfrm>
+          <a:prstGeom prst="rect">
+            <a:avLst/>
+          </a:prstGeom>
+          <a:noFill/>
+        </p:spPr>
+        <p:txBody>
+          <a:bodyPr wrap="square" anchor="b">
+            <a:noAutofit/>
+          </a:bodyPr>
+          <a:lstStyle/>
+          <a:p>
+            <a:pPr algn="r">
+              <a:lnSpc>
+                <a:spcPct val="100000"/>
+              </a:lnSpc>
+              <a:spcAft>
+                <a:spcPts val="0"/>
+              </a:spcAft>
+            </a:pPr>
+            <a:r>
+              <a:rPr sz="800">
+                <a:solidFill>
+                  <a:srgbClr val="7A88A3"/>
+                </a:solidFill>
+                <a:latin typeface="Calibri"/>
+              </a:rPr>
+              <a:t>AI — Artificial intelligence</a:t>
+            </a:r>
+          </a:p>
+          <a:p>
+            <a:pPr algn="r">
+              <a:lnSpc>
+                <a:spcPct val="100000"/>
+              </a:lnSpc>
+              <a:spcAft>
+                <a:spcPts val="0"/>
+              </a:spcAft>
+            </a:pPr>
+            <a:r>
+              <a:rPr sz="800">
+                <a:solidFill>
+                  <a:srgbClr val="7A88A3"/>
+                </a:solidFill>
+                <a:latin typeface="Calibri"/>
+              </a:rPr>
+              <a:t>UI — User interface</a:t>
+            </a:r>
+          </a:p>
+        </p:txBody>
+      </p:sp>
+      <p:pic>
+        <p:nvPicPr>
+          <p:cNvPr id="14" name="Picture 13" descr="riscon-mark-slide.png"/>
+          <p:cNvPicPr>
+            <a:picLocks noChangeAspect="1"/>
+          </p:cNvPicPr>
+          <p:nvPr/>
+        </p:nvPicPr>
+        <p:blipFill>
+          <a:blip r:embed="rId2"/>
+          <a:stretch>
+            <a:fillRect/>
+          </a:stretch>
+        </p:blipFill>
+        <p:spPr>
+          <a:xfrm>
+            <a:off x="10756087" y="502920"/>
+            <a:ext cx="932688" cy="932688"/>
+          </a:xfrm>
+          <a:prstGeom prst="rect">
+            <a:avLst/>
+          </a:prstGeom>
+        </p:spPr>
+      </p:pic>
     </p:spTree>
   </p:cSld>
   <p:clrMapOvr>
@@ -6358,7 +6609,7 @@
         <p:spPr>
           <a:xfrm>
             <a:off x="502920" y="1719072"/>
-            <a:ext cx="109728" cy="4636008"/>
+            <a:ext cx="109728" cy="3977639"/>
           </a:xfrm>
           <a:prstGeom prst="rect">
             <a:avLst/>
@@ -6401,7 +6652,7 @@
         <p:spPr>
           <a:xfrm>
             <a:off x="502920" y="1719072"/>
-            <a:ext cx="11185855" cy="4636008"/>
+            <a:ext cx="11185855" cy="3977640"/>
           </a:xfrm>
           <a:prstGeom prst="roundRect">
             <a:avLst/>
@@ -6446,7 +6697,7 @@
         <p:spPr>
           <a:xfrm>
             <a:off x="886968" y="2066544"/>
-            <a:ext cx="10472623" cy="4087368"/>
+            <a:ext cx="10472623" cy="3429000"/>
           </a:xfrm>
           <a:prstGeom prst="rect">
             <a:avLst/>
@@ -6912,6 +7163,262 @@
           </a:p>
         </p:txBody>
       </p:sp>
+      <p:sp>
+        <p:nvSpPr>
+          <p:cNvPr id="13" name="TextBox 12"/>
+          <p:cNvSpPr txBox="1"/>
+          <p:nvPr/>
+        </p:nvSpPr>
+        <p:spPr>
+          <a:xfrm>
+            <a:off x="7253935" y="5058463"/>
+            <a:ext cx="4434840" cy="1296617"/>
+          </a:xfrm>
+          <a:prstGeom prst="rect">
+            <a:avLst/>
+          </a:prstGeom>
+          <a:noFill/>
+        </p:spPr>
+        <p:txBody>
+          <a:bodyPr wrap="square" anchor="b">
+            <a:noAutofit/>
+          </a:bodyPr>
+          <a:lstStyle/>
+          <a:p>
+            <a:pPr algn="r">
+              <a:lnSpc>
+                <a:spcPct val="100000"/>
+              </a:lnSpc>
+              <a:spcAft>
+                <a:spcPts val="0"/>
+              </a:spcAft>
+            </a:pPr>
+            <a:r>
+              <a:rPr sz="800">
+                <a:solidFill>
+                  <a:srgbClr val="7A88A3"/>
+                </a:solidFill>
+                <a:latin typeface="Calibri"/>
+              </a:rPr>
+              <a:t>3PL — Third-party logistics</a:t>
+            </a:r>
+          </a:p>
+          <a:p>
+            <a:pPr algn="r">
+              <a:lnSpc>
+                <a:spcPct val="100000"/>
+              </a:lnSpc>
+              <a:spcAft>
+                <a:spcPts val="0"/>
+              </a:spcAft>
+            </a:pPr>
+            <a:r>
+              <a:rPr sz="800">
+                <a:solidFill>
+                  <a:srgbClr val="7A88A3"/>
+                </a:solidFill>
+                <a:latin typeface="Calibri"/>
+              </a:rPr>
+              <a:t>4PL — Fourth-party logistics</a:t>
+            </a:r>
+          </a:p>
+          <a:p>
+            <a:pPr algn="r">
+              <a:lnSpc>
+                <a:spcPct val="100000"/>
+              </a:lnSpc>
+              <a:spcAft>
+                <a:spcPts val="0"/>
+              </a:spcAft>
+            </a:pPr>
+            <a:r>
+              <a:rPr sz="800">
+                <a:solidFill>
+                  <a:srgbClr val="7A88A3"/>
+                </a:solidFill>
+                <a:latin typeface="Calibri"/>
+              </a:rPr>
+              <a:t>ACV — Annual contract value</a:t>
+            </a:r>
+          </a:p>
+          <a:p>
+            <a:pPr algn="r">
+              <a:lnSpc>
+                <a:spcPct val="100000"/>
+              </a:lnSpc>
+              <a:spcAft>
+                <a:spcPts val="0"/>
+              </a:spcAft>
+            </a:pPr>
+            <a:r>
+              <a:rPr sz="800">
+                <a:solidFill>
+                  <a:srgbClr val="7A88A3"/>
+                </a:solidFill>
+                <a:latin typeface="Calibri"/>
+              </a:rPr>
+              <a:t>AI — Artificial intelligence</a:t>
+            </a:r>
+          </a:p>
+          <a:p>
+            <a:pPr algn="r">
+              <a:lnSpc>
+                <a:spcPct val="100000"/>
+              </a:lnSpc>
+              <a:spcAft>
+                <a:spcPts val="0"/>
+              </a:spcAft>
+            </a:pPr>
+            <a:r>
+              <a:rPr sz="800">
+                <a:solidFill>
+                  <a:srgbClr val="7A88A3"/>
+                </a:solidFill>
+                <a:latin typeface="Calibri"/>
+              </a:rPr>
+              <a:t>CAC — Customer acquisition cost</a:t>
+            </a:r>
+          </a:p>
+          <a:p>
+            <a:pPr algn="r">
+              <a:lnSpc>
+                <a:spcPct val="100000"/>
+              </a:lnSpc>
+              <a:spcAft>
+                <a:spcPts val="0"/>
+              </a:spcAft>
+            </a:pPr>
+            <a:r>
+              <a:rPr sz="800">
+                <a:solidFill>
+                  <a:srgbClr val="7A88A3"/>
+                </a:solidFill>
+                <a:latin typeface="Calibri"/>
+              </a:rPr>
+              <a:t>CPO — Chief procurement officer</a:t>
+            </a:r>
+          </a:p>
+          <a:p>
+            <a:pPr algn="r">
+              <a:lnSpc>
+                <a:spcPct val="100000"/>
+              </a:lnSpc>
+              <a:spcAft>
+                <a:spcPts val="0"/>
+              </a:spcAft>
+            </a:pPr>
+            <a:r>
+              <a:rPr sz="800">
+                <a:solidFill>
+                  <a:srgbClr val="7A88A3"/>
+                </a:solidFill>
+                <a:latin typeface="Calibri"/>
+              </a:rPr>
+              <a:t>GTM — Go-to-market</a:t>
+            </a:r>
+          </a:p>
+          <a:p>
+            <a:pPr algn="r">
+              <a:lnSpc>
+                <a:spcPct val="100000"/>
+              </a:lnSpc>
+              <a:spcAft>
+                <a:spcPts val="0"/>
+              </a:spcAft>
+            </a:pPr>
+            <a:r>
+              <a:rPr sz="800">
+                <a:solidFill>
+                  <a:srgbClr val="7A88A3"/>
+                </a:solidFill>
+                <a:latin typeface="Calibri"/>
+              </a:rPr>
+              <a:t>ICP — Ideal customer profile</a:t>
+            </a:r>
+          </a:p>
+          <a:p>
+            <a:pPr algn="r">
+              <a:lnSpc>
+                <a:spcPct val="100000"/>
+              </a:lnSpc>
+              <a:spcAft>
+                <a:spcPts val="0"/>
+              </a:spcAft>
+            </a:pPr>
+            <a:r>
+              <a:rPr sz="800">
+                <a:solidFill>
+                  <a:srgbClr val="7A88A3"/>
+                </a:solidFill>
+                <a:latin typeface="Calibri"/>
+              </a:rPr>
+              <a:t>IHK — Chamber of Commerce and Industry (Germany)</a:t>
+            </a:r>
+          </a:p>
+          <a:p>
+            <a:pPr algn="r">
+              <a:lnSpc>
+                <a:spcPct val="100000"/>
+              </a:lnSpc>
+              <a:spcAft>
+                <a:spcPts val="0"/>
+              </a:spcAft>
+            </a:pPr>
+            <a:r>
+              <a:rPr sz="800">
+                <a:solidFill>
+                  <a:srgbClr val="7A88A3"/>
+                </a:solidFill>
+                <a:latin typeface="Calibri"/>
+              </a:rPr>
+              <a:t>LLM — Large language model</a:t>
+            </a:r>
+          </a:p>
+          <a:p>
+            <a:pPr algn="r">
+              <a:lnSpc>
+                <a:spcPct val="100000"/>
+              </a:lnSpc>
+              <a:spcAft>
+                <a:spcPts val="0"/>
+              </a:spcAft>
+            </a:pPr>
+            <a:r>
+              <a:rPr sz="800">
+                <a:solidFill>
+                  <a:srgbClr val="7A88A3"/>
+                </a:solidFill>
+                <a:latin typeface="Calibri"/>
+              </a:rPr>
+              <a:t>VDMA — German Engineering Federation (Verband)</a:t>
+            </a:r>
+          </a:p>
+        </p:txBody>
+      </p:sp>
+      <p:pic>
+        <p:nvPicPr>
+          <p:cNvPr id="14" name="Picture 13" descr="riscon-mark-slide.png"/>
+          <p:cNvPicPr>
+            <a:picLocks noChangeAspect="1"/>
+          </p:cNvPicPr>
+          <p:nvPr/>
+        </p:nvPicPr>
+        <p:blipFill>
+          <a:blip r:embed="rId2"/>
+          <a:stretch>
+            <a:fillRect/>
+          </a:stretch>
+        </p:blipFill>
+        <p:spPr>
+          <a:xfrm>
+            <a:off x="10756087" y="502920"/>
+            <a:ext cx="932688" cy="932688"/>
+          </a:xfrm>
+          <a:prstGeom prst="rect">
+            <a:avLst/>
+          </a:prstGeom>
+        </p:spPr>
+      </p:pic>
     </p:spTree>
   </p:cSld>
   <p:clrMapOvr>
@@ -7680,6 +8187,30 @@
           </a:p>
         </p:txBody>
       </p:sp>
+      <p:pic>
+        <p:nvPicPr>
+          <p:cNvPr id="13" name="Picture 12" descr="riscon-mark-slide.png"/>
+          <p:cNvPicPr>
+            <a:picLocks noChangeAspect="1"/>
+          </p:cNvPicPr>
+          <p:nvPr/>
+        </p:nvPicPr>
+        <p:blipFill>
+          <a:blip r:embed="rId2"/>
+          <a:stretch>
+            <a:fillRect/>
+          </a:stretch>
+        </p:blipFill>
+        <p:spPr>
+          <a:xfrm>
+            <a:off x="10756087" y="502920"/>
+            <a:ext cx="932688" cy="932688"/>
+          </a:xfrm>
+          <a:prstGeom prst="rect">
+            <a:avLst/>
+          </a:prstGeom>
+        </p:spPr>
+      </p:pic>
     </p:spTree>
   </p:cSld>
   <p:clrMapOvr>
@@ -8035,7 +8566,7 @@
         <p:spPr>
           <a:xfrm>
             <a:off x="502920" y="1719072"/>
-            <a:ext cx="109728" cy="4636008"/>
+            <a:ext cx="109728" cy="3977639"/>
           </a:xfrm>
           <a:prstGeom prst="rect">
             <a:avLst/>
@@ -8078,7 +8609,7 @@
         <p:spPr>
           <a:xfrm>
             <a:off x="502920" y="1719072"/>
-            <a:ext cx="11185855" cy="4636008"/>
+            <a:ext cx="11185855" cy="3977640"/>
           </a:xfrm>
           <a:prstGeom prst="roundRect">
             <a:avLst/>
@@ -8123,7 +8654,7 @@
         <p:spPr>
           <a:xfrm>
             <a:off x="886968" y="2066544"/>
-            <a:ext cx="10472623" cy="4087368"/>
+            <a:ext cx="10472623" cy="3429000"/>
           </a:xfrm>
           <a:prstGeom prst="rect">
             <a:avLst/>
@@ -8712,6 +9243,91 @@
           </a:p>
         </p:txBody>
       </p:sp>
+      <p:sp>
+        <p:nvSpPr>
+          <p:cNvPr id="13" name="TextBox 12"/>
+          <p:cNvSpPr txBox="1"/>
+          <p:nvPr/>
+        </p:nvSpPr>
+        <p:spPr>
+          <a:xfrm>
+            <a:off x="7253935" y="6029554"/>
+            <a:ext cx="4434840" cy="325526"/>
+          </a:xfrm>
+          <a:prstGeom prst="rect">
+            <a:avLst/>
+          </a:prstGeom>
+          <a:noFill/>
+        </p:spPr>
+        <p:txBody>
+          <a:bodyPr wrap="square" anchor="b">
+            <a:noAutofit/>
+          </a:bodyPr>
+          <a:lstStyle/>
+          <a:p>
+            <a:pPr algn="r">
+              <a:lnSpc>
+                <a:spcPct val="100000"/>
+              </a:lnSpc>
+              <a:spcAft>
+                <a:spcPts val="0"/>
+              </a:spcAft>
+            </a:pPr>
+            <a:r>
+              <a:rPr sz="800">
+                <a:solidFill>
+                  <a:srgbClr val="7A88A3"/>
+                </a:solidFill>
+                <a:latin typeface="Calibri"/>
+              </a:rPr>
+              <a:t>API — Application programming interface</a:t>
+            </a:r>
+          </a:p>
+          <a:p>
+            <a:pPr algn="r">
+              <a:lnSpc>
+                <a:spcPct val="100000"/>
+              </a:lnSpc>
+              <a:spcAft>
+                <a:spcPts val="0"/>
+              </a:spcAft>
+            </a:pPr>
+            <a:r>
+              <a:rPr sz="800">
+                <a:solidFill>
+                  <a:srgbClr val="7A88A3"/>
+                </a:solidFill>
+                <a:latin typeface="Calibri"/>
+              </a:rPr>
+              <a:t>LLM — Large language model</a:t>
+            </a:r>
+          </a:p>
+        </p:txBody>
+      </p:sp>
+      <p:pic>
+        <p:nvPicPr>
+          <p:cNvPr id="14" name="Picture 13" descr="riscon-mark-slide.png"/>
+          <p:cNvPicPr>
+            <a:picLocks noChangeAspect="1"/>
+          </p:cNvPicPr>
+          <p:nvPr/>
+        </p:nvPicPr>
+        <p:blipFill>
+          <a:blip r:embed="rId2"/>
+          <a:stretch>
+            <a:fillRect/>
+          </a:stretch>
+        </p:blipFill>
+        <p:spPr>
+          <a:xfrm>
+            <a:off x="10756087" y="502920"/>
+            <a:ext cx="932688" cy="932688"/>
+          </a:xfrm>
+          <a:prstGeom prst="rect">
+            <a:avLst/>
+          </a:prstGeom>
+        </p:spPr>
+      </p:pic>
     </p:spTree>
   </p:cSld>
   <p:clrMapOvr>
@@ -9093,6 +9709,30 @@
           </a:p>
         </p:txBody>
       </p:sp>
+      <p:pic>
+        <p:nvPicPr>
+          <p:cNvPr id="11" name="Picture 10" descr="riscon-mark-slide.png"/>
+          <p:cNvPicPr>
+            <a:picLocks noChangeAspect="1"/>
+          </p:cNvPicPr>
+          <p:nvPr/>
+        </p:nvPicPr>
+        <p:blipFill>
+          <a:blip r:embed="rId2"/>
+          <a:stretch>
+            <a:fillRect/>
+          </a:stretch>
+        </p:blipFill>
+        <p:spPr>
+          <a:xfrm>
+            <a:off x="10756087" y="502920"/>
+            <a:ext cx="932688" cy="932688"/>
+          </a:xfrm>
+          <a:prstGeom prst="rect">
+            <a:avLst/>
+          </a:prstGeom>
+        </p:spPr>
+      </p:pic>
     </p:spTree>
   </p:cSld>
   <p:clrMapOvr>

</xml_diff>